<commit_message>
Usar el nuevo diagrama E/R en la memoria PDF y en la presentación
</commit_message>
<xml_diff>
--- a/docs/Presentacion.pptx
+++ b/docs/Presentacion.pptx
@@ -2460,7 +2460,7 @@
           <a:p>
             <a:r>
               <a:rPr lang="en-US" dirty="0"/>
-              <a:t>Ponente 3. Recorre el diagrama de izquierda a derecha: Alumnos realiza Proyectos (con la evaluación), Alumnos pertenece a Promoción, Promoción tiene Proyectos y Promoción tiene Claustro. Señala que la modalidad está en el claustro porque solo claustro.csv trae ese dato, y que en una misma promoción hay profesores presenciales (TA) y online (LI). Da paso al Ponente 4: “Ahora hay que convertir este dibujo en tablas”.</a:t>
+              <a:t>Ponente 3. Recorre el diagrama de izquierda a derecha: Alumnos realiza Proyectos (con la evaluación), Alumnos pertenece a Promoción, Promoción tiene Proyectos y Promoción tiene Claustro. Señala la modalidad: en el claustro, la de cada profesor (en una misma promoción hay TA presenciales y LI online), y en la promoción, TipoModalidad. Da paso al Ponente 4: “Ahora hay que convertir este dibujo en tablas”.</a:t>
             </a:r>
             <a:endParaRPr lang="en-US" dirty="0"/>
           </a:p>
@@ -24509,18 +24509,17 @@
         </p:nvPicPr>
         <p:blipFill>
           <a:blip r:embed="rId1"/>
-          <a:srcRect l="-159" r="-159" t="0" b="0"/>
-          <a:stretch/>
+          <a:stretch>
+            <a:fillRect/>
+          </a:stretch>
         </p:blipFill>
         <p:spPr>
           <a:xfrm>
-            <a:off x="825500" y="1531541"/>
-            <a:ext cx="7467600" cy="3987800"/>
-          </a:xfrm>
-          <a:prstGeom prst="roundRect">
-            <a:avLst>
-              <a:gd name="adj" fmla="val 2229"/>
-            </a:avLst>
+            <a:off x="825500" y="1696285"/>
+            <a:ext cx="7467600" cy="3658311"/>
+          </a:xfrm>
+          <a:prstGeom prst="rect">
+            <a:avLst/>
           </a:prstGeom>
         </p:spPr>
       </p:pic>
@@ -24899,29 +24898,6 @@
           </a:p>
         </p:txBody>
       </p:sp>
-      <p:pic>
-        <p:nvPicPr>
-          <p:cNvPr id="12" name="Image 1" descr="image.png">    </p:cNvPr>
-          <p:cNvPicPr>
-            <a:picLocks noChangeAspect="1"/>
-          </p:cNvPicPr>
-          <p:nvPr/>
-        </p:nvPicPr>
-        <p:blipFill>
-          <a:blip r:embed="rId2"/>
-          <a:srcRect l="0" r="0" t="340" b="340"/>
-          <a:stretch/>
-        </p:blipFill>
-        <p:spPr>
-          <a:xfrm>
-            <a:off x="812800" y="1829246"/>
-            <a:ext cx="7452916" cy="3665637"/>
-          </a:xfrm>
-          <a:prstGeom prst="rect">
-            <a:avLst/>
-          </a:prstGeom>
-        </p:spPr>
-      </p:pic>
     </p:spTree>
   </p:cSld>
   <p:clrMapOvr>

</xml_diff>